<commit_message>
Fix data, add text to correlation
</commit_message>
<xml_diff>
--- a/report_and_presentation/Cohort8_DS3_Presentation.pptx
+++ b/report_and_presentation/Cohort8_DS3_Presentation.pptx
@@ -129,7 +129,18 @@
   </p:defaultTextStyle>
   <p:extLst>
     <p:ext uri="{EFAFB233-063F-42B5-8137-9DF3F51BA10A}">
-      <p15:sldGuideLst xmlns:p15="http://schemas.microsoft.com/office/powerpoint/2012/main" xmlns=""/>
+      <p15:sldGuideLst xmlns:p15="http://schemas.microsoft.com/office/powerpoint/2012/main">
+        <p15:guide id="1" orient="horz" pos="2160">
+          <p15:clr>
+            <a:srgbClr val="A4A3A4"/>
+          </p15:clr>
+        </p15:guide>
+        <p15:guide id="2" pos="3840">
+          <p15:clr>
+            <a:srgbClr val="A4A3A4"/>
+          </p15:clr>
+        </p15:guide>
+      </p15:sldGuideLst>
     </p:ext>
   </p:extLst>
 </p:presentation>
@@ -217,7 +228,7 @@
           <a:p>
             <a:fld id="{318D9752-18F5-491D-A8FE-927E5AB031AE}" type="datetimeFigureOut">
               <a:rPr lang="en-CA" smtClean="0"/>
-              <a:t>2026-03-05</a:t>
+              <a:t>2026-03-06</a:t>
             </a:fld>
             <a:endParaRPr lang="en-CA"/>
           </a:p>
@@ -597,7 +608,7 @@
         <p:cNvPr id="1" name="Shape 271">
           <a:extLst>
             <a:ext uri="{FF2B5EF4-FFF2-40B4-BE49-F238E27FC236}">
-              <a16:creationId xmlns:a16="http://schemas.microsoft.com/office/drawing/2014/main" xmlns="" id="{30E5B0FF-7F6A-5BBA-FD84-E67D98E0CA07}"/>
+              <a16:creationId xmlns:a16="http://schemas.microsoft.com/office/drawing/2014/main" id="{30E5B0FF-7F6A-5BBA-FD84-E67D98E0CA07}"/>
             </a:ext>
           </a:extLst>
         </p:cNvPr>
@@ -617,7 +628,7 @@
           <p:cNvPr id="272" name="Google Shape;272;p11:notes">
             <a:extLst>
               <a:ext uri="{FF2B5EF4-FFF2-40B4-BE49-F238E27FC236}">
-                <a16:creationId xmlns:a16="http://schemas.microsoft.com/office/drawing/2014/main" xmlns="" id="{58156EA9-AE74-DAA2-37EE-FD21A1D01AE0}"/>
+                <a16:creationId xmlns:a16="http://schemas.microsoft.com/office/drawing/2014/main" id="{58156EA9-AE74-DAA2-37EE-FD21A1D01AE0}"/>
               </a:ext>
             </a:extLst>
           </p:cNvPr>
@@ -661,7 +672,7 @@
           <p:cNvPr id="273" name="Google Shape;273;p11:notes">
             <a:extLst>
               <a:ext uri="{FF2B5EF4-FFF2-40B4-BE49-F238E27FC236}">
-                <a16:creationId xmlns:a16="http://schemas.microsoft.com/office/drawing/2014/main" xmlns="" id="{4D6DA1AF-9CBF-94BE-DAF7-11CC472703EE}"/>
+                <a16:creationId xmlns:a16="http://schemas.microsoft.com/office/drawing/2014/main" id="{4D6DA1AF-9CBF-94BE-DAF7-11CC472703EE}"/>
               </a:ext>
             </a:extLst>
           </p:cNvPr>
@@ -724,7 +735,7 @@
         <p:cNvPr id="1" name="Shape 271">
           <a:extLst>
             <a:ext uri="{FF2B5EF4-FFF2-40B4-BE49-F238E27FC236}">
-              <a16:creationId xmlns:a16="http://schemas.microsoft.com/office/drawing/2014/main" xmlns="" id="{0B5CE19B-28C4-4D25-EB9B-439810A6455F}"/>
+              <a16:creationId xmlns:a16="http://schemas.microsoft.com/office/drawing/2014/main" id="{0B5CE19B-28C4-4D25-EB9B-439810A6455F}"/>
             </a:ext>
           </a:extLst>
         </p:cNvPr>
@@ -744,7 +755,7 @@
           <p:cNvPr id="272" name="Google Shape;272;p11:notes">
             <a:extLst>
               <a:ext uri="{FF2B5EF4-FFF2-40B4-BE49-F238E27FC236}">
-                <a16:creationId xmlns:a16="http://schemas.microsoft.com/office/drawing/2014/main" xmlns="" id="{73B21E0F-8B08-FC1B-D07F-7E6E02321723}"/>
+                <a16:creationId xmlns:a16="http://schemas.microsoft.com/office/drawing/2014/main" id="{73B21E0F-8B08-FC1B-D07F-7E6E02321723}"/>
               </a:ext>
             </a:extLst>
           </p:cNvPr>
@@ -788,7 +799,7 @@
           <p:cNvPr id="273" name="Google Shape;273;p11:notes">
             <a:extLst>
               <a:ext uri="{FF2B5EF4-FFF2-40B4-BE49-F238E27FC236}">
-                <a16:creationId xmlns:a16="http://schemas.microsoft.com/office/drawing/2014/main" xmlns="" id="{243BF204-1B95-C87B-6715-B2949BED2E18}"/>
+                <a16:creationId xmlns:a16="http://schemas.microsoft.com/office/drawing/2014/main" id="{243BF204-1B95-C87B-6715-B2949BED2E18}"/>
               </a:ext>
             </a:extLst>
           </p:cNvPr>
@@ -1059,7 +1070,7 @@
         <p:cNvPr id="1" name="Shape 271">
           <a:extLst>
             <a:ext uri="{FF2B5EF4-FFF2-40B4-BE49-F238E27FC236}">
-              <a16:creationId xmlns:a16="http://schemas.microsoft.com/office/drawing/2014/main" xmlns="" id="{92943E5C-15F6-54E9-B745-B30B17AAB483}"/>
+              <a16:creationId xmlns:a16="http://schemas.microsoft.com/office/drawing/2014/main" id="{92943E5C-15F6-54E9-B745-B30B17AAB483}"/>
             </a:ext>
           </a:extLst>
         </p:cNvPr>
@@ -1079,7 +1090,7 @@
           <p:cNvPr id="272" name="Google Shape;272;p11:notes">
             <a:extLst>
               <a:ext uri="{FF2B5EF4-FFF2-40B4-BE49-F238E27FC236}">
-                <a16:creationId xmlns:a16="http://schemas.microsoft.com/office/drawing/2014/main" xmlns="" id="{43D16254-6F56-28A8-E72D-69E13CA5F982}"/>
+                <a16:creationId xmlns:a16="http://schemas.microsoft.com/office/drawing/2014/main" id="{43D16254-6F56-28A8-E72D-69E13CA5F982}"/>
               </a:ext>
             </a:extLst>
           </p:cNvPr>
@@ -1123,7 +1134,7 @@
           <p:cNvPr id="273" name="Google Shape;273;p11:notes">
             <a:extLst>
               <a:ext uri="{FF2B5EF4-FFF2-40B4-BE49-F238E27FC236}">
-                <a16:creationId xmlns:a16="http://schemas.microsoft.com/office/drawing/2014/main" xmlns="" id="{6A221F69-FA65-4CC9-B4D5-4663971FD65F}"/>
+                <a16:creationId xmlns:a16="http://schemas.microsoft.com/office/drawing/2014/main" id="{6A221F69-FA65-4CC9-B4D5-4663971FD65F}"/>
               </a:ext>
             </a:extLst>
           </p:cNvPr>
@@ -1186,7 +1197,7 @@
         <p:cNvPr id="1" name="Shape 271">
           <a:extLst>
             <a:ext uri="{FF2B5EF4-FFF2-40B4-BE49-F238E27FC236}">
-              <a16:creationId xmlns:a16="http://schemas.microsoft.com/office/drawing/2014/main" xmlns="" id="{92943E5C-15F6-54E9-B745-B30B17AAB483}"/>
+              <a16:creationId xmlns:a16="http://schemas.microsoft.com/office/drawing/2014/main" id="{92943E5C-15F6-54E9-B745-B30B17AAB483}"/>
             </a:ext>
           </a:extLst>
         </p:cNvPr>
@@ -1206,7 +1217,7 @@
           <p:cNvPr id="272" name="Google Shape;272;p11:notes">
             <a:extLst>
               <a:ext uri="{FF2B5EF4-FFF2-40B4-BE49-F238E27FC236}">
-                <a16:creationId xmlns:a16="http://schemas.microsoft.com/office/drawing/2014/main" xmlns="" id="{43D16254-6F56-28A8-E72D-69E13CA5F982}"/>
+                <a16:creationId xmlns:a16="http://schemas.microsoft.com/office/drawing/2014/main" id="{43D16254-6F56-28A8-E72D-69E13CA5F982}"/>
               </a:ext>
             </a:extLst>
           </p:cNvPr>
@@ -1250,7 +1261,7 @@
           <p:cNvPr id="273" name="Google Shape;273;p11:notes">
             <a:extLst>
               <a:ext uri="{FF2B5EF4-FFF2-40B4-BE49-F238E27FC236}">
-                <a16:creationId xmlns:a16="http://schemas.microsoft.com/office/drawing/2014/main" xmlns="" id="{6A221F69-FA65-4CC9-B4D5-4663971FD65F}"/>
+                <a16:creationId xmlns:a16="http://schemas.microsoft.com/office/drawing/2014/main" id="{6A221F69-FA65-4CC9-B4D5-4663971FD65F}"/>
               </a:ext>
             </a:extLst>
           </p:cNvPr>
@@ -1521,7 +1532,7 @@
         <p:cNvPr id="1" name="Shape 260">
           <a:extLst>
             <a:ext uri="{FF2B5EF4-FFF2-40B4-BE49-F238E27FC236}">
-              <a16:creationId xmlns:a16="http://schemas.microsoft.com/office/drawing/2014/main" xmlns="" id="{031ADCA6-ED41-89E8-8C5D-A7C0A46EC911}"/>
+              <a16:creationId xmlns:a16="http://schemas.microsoft.com/office/drawing/2014/main" id="{031ADCA6-ED41-89E8-8C5D-A7C0A46EC911}"/>
             </a:ext>
           </a:extLst>
         </p:cNvPr>
@@ -1541,7 +1552,7 @@
           <p:cNvPr id="261" name="Google Shape;261;p10:notes">
             <a:extLst>
               <a:ext uri="{FF2B5EF4-FFF2-40B4-BE49-F238E27FC236}">
-                <a16:creationId xmlns:a16="http://schemas.microsoft.com/office/drawing/2014/main" xmlns="" id="{76B5FB3A-981F-7241-F06A-19C82D27A25B}"/>
+                <a16:creationId xmlns:a16="http://schemas.microsoft.com/office/drawing/2014/main" id="{76B5FB3A-981F-7241-F06A-19C82D27A25B}"/>
               </a:ext>
             </a:extLst>
           </p:cNvPr>
@@ -1585,7 +1596,7 @@
           <p:cNvPr id="262" name="Google Shape;262;p10:notes">
             <a:extLst>
               <a:ext uri="{FF2B5EF4-FFF2-40B4-BE49-F238E27FC236}">
-                <a16:creationId xmlns:a16="http://schemas.microsoft.com/office/drawing/2014/main" xmlns="" id="{15698202-36E2-7700-F89A-43A791D1B102}"/>
+                <a16:creationId xmlns:a16="http://schemas.microsoft.com/office/drawing/2014/main" id="{15698202-36E2-7700-F89A-43A791D1B102}"/>
               </a:ext>
             </a:extLst>
           </p:cNvPr>
@@ -1648,7 +1659,7 @@
         <p:cNvPr id="1" name="Shape 260">
           <a:extLst>
             <a:ext uri="{FF2B5EF4-FFF2-40B4-BE49-F238E27FC236}">
-              <a16:creationId xmlns:a16="http://schemas.microsoft.com/office/drawing/2014/main" xmlns="" id="{0E976981-14AE-3DC3-9973-EF0F0CADCAEB}"/>
+              <a16:creationId xmlns:a16="http://schemas.microsoft.com/office/drawing/2014/main" id="{0E976981-14AE-3DC3-9973-EF0F0CADCAEB}"/>
             </a:ext>
           </a:extLst>
         </p:cNvPr>
@@ -1668,7 +1679,7 @@
           <p:cNvPr id="261" name="Google Shape;261;p10:notes">
             <a:extLst>
               <a:ext uri="{FF2B5EF4-FFF2-40B4-BE49-F238E27FC236}">
-                <a16:creationId xmlns:a16="http://schemas.microsoft.com/office/drawing/2014/main" xmlns="" id="{FA607C5C-DCD1-5349-A7DF-6FC75E5ED5A2}"/>
+                <a16:creationId xmlns:a16="http://schemas.microsoft.com/office/drawing/2014/main" id="{FA607C5C-DCD1-5349-A7DF-6FC75E5ED5A2}"/>
               </a:ext>
             </a:extLst>
           </p:cNvPr>
@@ -1712,7 +1723,7 @@
           <p:cNvPr id="262" name="Google Shape;262;p10:notes">
             <a:extLst>
               <a:ext uri="{FF2B5EF4-FFF2-40B4-BE49-F238E27FC236}">
-                <a16:creationId xmlns:a16="http://schemas.microsoft.com/office/drawing/2014/main" xmlns="" id="{1C481F5B-62F5-FF71-90D8-F8B7AC3FE442}"/>
+                <a16:creationId xmlns:a16="http://schemas.microsoft.com/office/drawing/2014/main" id="{1C481F5B-62F5-FF71-90D8-F8B7AC3FE442}"/>
               </a:ext>
             </a:extLst>
           </p:cNvPr>
@@ -1775,7 +1786,7 @@
         <p:cNvPr id="1" name="Shape 271">
           <a:extLst>
             <a:ext uri="{FF2B5EF4-FFF2-40B4-BE49-F238E27FC236}">
-              <a16:creationId xmlns:a16="http://schemas.microsoft.com/office/drawing/2014/main" xmlns="" id="{491CAB47-D3CB-8D12-095A-517DD5602BF3}"/>
+              <a16:creationId xmlns:a16="http://schemas.microsoft.com/office/drawing/2014/main" id="{491CAB47-D3CB-8D12-095A-517DD5602BF3}"/>
             </a:ext>
           </a:extLst>
         </p:cNvPr>
@@ -1795,7 +1806,7 @@
           <p:cNvPr id="272" name="Google Shape;272;p11:notes">
             <a:extLst>
               <a:ext uri="{FF2B5EF4-FFF2-40B4-BE49-F238E27FC236}">
-                <a16:creationId xmlns:a16="http://schemas.microsoft.com/office/drawing/2014/main" xmlns="" id="{12DFE4D8-9CD7-C8F2-B8DA-9C7304EF86EB}"/>
+                <a16:creationId xmlns:a16="http://schemas.microsoft.com/office/drawing/2014/main" id="{12DFE4D8-9CD7-C8F2-B8DA-9C7304EF86EB}"/>
               </a:ext>
             </a:extLst>
           </p:cNvPr>
@@ -1839,7 +1850,7 @@
           <p:cNvPr id="273" name="Google Shape;273;p11:notes">
             <a:extLst>
               <a:ext uri="{FF2B5EF4-FFF2-40B4-BE49-F238E27FC236}">
-                <a16:creationId xmlns:a16="http://schemas.microsoft.com/office/drawing/2014/main" xmlns="" id="{2E3771D8-16F3-1D78-85D9-6F890316ECA3}"/>
+                <a16:creationId xmlns:a16="http://schemas.microsoft.com/office/drawing/2014/main" id="{2E3771D8-16F3-1D78-85D9-6F890316ECA3}"/>
               </a:ext>
             </a:extLst>
           </p:cNvPr>
@@ -1938,7 +1949,7 @@
           </a:lstStyle>
           <a:p>
             <a:r>
-              <a:rPr lang="en-US" smtClean="0"/>
+              <a:rPr lang="en-US"/>
               <a:t>Click to edit Master title style</a:t>
             </a:r>
             <a:endParaRPr lang="en-US" dirty="0"/>
@@ -2058,7 +2069,7 @@
           </a:lstStyle>
           <a:p>
             <a:r>
-              <a:rPr lang="en-US" smtClean="0"/>
+              <a:rPr lang="en-US"/>
               <a:t>Click to edit Master subtitle style</a:t>
             </a:r>
             <a:endParaRPr lang="en-US" dirty="0"/>
@@ -2082,7 +2093,7 @@
           <a:p>
             <a:fld id="{F4D18BF0-D309-41FF-AA8C-FC2AA1806513}" type="datetimeFigureOut">
               <a:rPr lang="en-US" smtClean="0"/>
-              <a:t>3/5/2026</a:t>
+              <a:t>3/6/2026</a:t>
             </a:fld>
             <a:endParaRPr lang="en-US"/>
           </a:p>
@@ -2206,10 +2217,9 @@
           <a:lstStyle/>
           <a:p>
             <a:r>
-              <a:rPr lang="en-US" smtClean="0"/>
+              <a:rPr lang="en-US"/>
               <a:t>Click to edit Master title style</a:t>
             </a:r>
-            <a:endParaRPr lang="en-US"/>
           </a:p>
         </p:txBody>
       </p:sp>
@@ -2230,38 +2240,37 @@
           <a:p>
             <a:pPr lvl="0"/>
             <a:r>
-              <a:rPr lang="en-US" smtClean="0"/>
+              <a:rPr lang="en-US"/>
               <a:t>Click to edit Master text styles</a:t>
             </a:r>
           </a:p>
           <a:p>
             <a:pPr lvl="1"/>
             <a:r>
-              <a:rPr lang="en-US" smtClean="0"/>
+              <a:rPr lang="en-US"/>
               <a:t>Second level</a:t>
             </a:r>
           </a:p>
           <a:p>
             <a:pPr lvl="2"/>
             <a:r>
-              <a:rPr lang="en-US" smtClean="0"/>
+              <a:rPr lang="en-US"/>
               <a:t>Third level</a:t>
             </a:r>
           </a:p>
           <a:p>
             <a:pPr lvl="3"/>
             <a:r>
-              <a:rPr lang="en-US" smtClean="0"/>
+              <a:rPr lang="en-US"/>
               <a:t>Fourth level</a:t>
             </a:r>
           </a:p>
           <a:p>
             <a:pPr lvl="4"/>
             <a:r>
-              <a:rPr lang="en-US" smtClean="0"/>
+              <a:rPr lang="en-US"/>
               <a:t>Fifth level</a:t>
             </a:r>
-            <a:endParaRPr lang="en-US"/>
           </a:p>
         </p:txBody>
       </p:sp>
@@ -2282,7 +2291,7 @@
           <a:p>
             <a:fld id="{F4D18BF0-D309-41FF-AA8C-FC2AA1806513}" type="datetimeFigureOut">
               <a:rPr lang="en-US" smtClean="0"/>
-              <a:t>3/5/2026</a:t>
+              <a:t>3/6/2026</a:t>
             </a:fld>
             <a:endParaRPr lang="en-US"/>
           </a:p>
@@ -2376,7 +2385,7 @@
           <a:lstStyle/>
           <a:p>
             <a:r>
-              <a:rPr lang="en-US" smtClean="0"/>
+              <a:rPr lang="en-US"/>
               <a:t>Click to edit Master title style</a:t>
             </a:r>
             <a:endParaRPr lang="en-US" dirty="0"/>
@@ -2405,35 +2414,35 @@
           <a:p>
             <a:pPr lvl="0"/>
             <a:r>
-              <a:rPr lang="en-US" smtClean="0"/>
+              <a:rPr lang="en-US"/>
               <a:t>Click to edit Master text styles</a:t>
             </a:r>
           </a:p>
           <a:p>
             <a:pPr lvl="1"/>
             <a:r>
-              <a:rPr lang="en-US" smtClean="0"/>
+              <a:rPr lang="en-US"/>
               <a:t>Second level</a:t>
             </a:r>
           </a:p>
           <a:p>
             <a:pPr lvl="2"/>
             <a:r>
-              <a:rPr lang="en-US" smtClean="0"/>
+              <a:rPr lang="en-US"/>
               <a:t>Third level</a:t>
             </a:r>
           </a:p>
           <a:p>
             <a:pPr lvl="3"/>
             <a:r>
-              <a:rPr lang="en-US" smtClean="0"/>
+              <a:rPr lang="en-US"/>
               <a:t>Fourth level</a:t>
             </a:r>
           </a:p>
           <a:p>
             <a:pPr lvl="4"/>
             <a:r>
-              <a:rPr lang="en-US" smtClean="0"/>
+              <a:rPr lang="en-US"/>
               <a:t>Fifth level</a:t>
             </a:r>
             <a:endParaRPr lang="en-US" dirty="0"/>
@@ -2457,7 +2466,7 @@
           <a:p>
             <a:fld id="{F4D18BF0-D309-41FF-AA8C-FC2AA1806513}" type="datetimeFigureOut">
               <a:rPr lang="en-US" smtClean="0"/>
-              <a:t>3/5/2026</a:t>
+              <a:t>3/6/2026</a:t>
             </a:fld>
             <a:endParaRPr lang="en-US"/>
           </a:p>
@@ -2546,10 +2555,9 @@
           <a:lstStyle/>
           <a:p>
             <a:r>
-              <a:rPr lang="en-US" smtClean="0"/>
+              <a:rPr lang="en-US"/>
               <a:t>Click to edit Master title style</a:t>
             </a:r>
-            <a:endParaRPr lang="en-US"/>
           </a:p>
         </p:txBody>
       </p:sp>
@@ -2570,38 +2578,37 @@
           <a:p>
             <a:pPr lvl="0"/>
             <a:r>
-              <a:rPr lang="en-US" smtClean="0"/>
+              <a:rPr lang="en-US"/>
               <a:t>Click to edit Master text styles</a:t>
             </a:r>
           </a:p>
           <a:p>
             <a:pPr lvl="1"/>
             <a:r>
-              <a:rPr lang="en-US" smtClean="0"/>
+              <a:rPr lang="en-US"/>
               <a:t>Second level</a:t>
             </a:r>
           </a:p>
           <a:p>
             <a:pPr lvl="2"/>
             <a:r>
-              <a:rPr lang="en-US" smtClean="0"/>
+              <a:rPr lang="en-US"/>
               <a:t>Third level</a:t>
             </a:r>
           </a:p>
           <a:p>
             <a:pPr lvl="3"/>
             <a:r>
-              <a:rPr lang="en-US" smtClean="0"/>
+              <a:rPr lang="en-US"/>
               <a:t>Fourth level</a:t>
             </a:r>
           </a:p>
           <a:p>
             <a:pPr lvl="4"/>
             <a:r>
-              <a:rPr lang="en-US" smtClean="0"/>
+              <a:rPr lang="en-US"/>
               <a:t>Fifth level</a:t>
             </a:r>
-            <a:endParaRPr lang="en-US"/>
           </a:p>
         </p:txBody>
       </p:sp>
@@ -2622,7 +2629,7 @@
           <a:p>
             <a:fld id="{F4D18BF0-D309-41FF-AA8C-FC2AA1806513}" type="datetimeFigureOut">
               <a:rPr lang="en-US" smtClean="0"/>
-              <a:t>3/5/2026</a:t>
+              <a:t>3/6/2026</a:t>
             </a:fld>
             <a:endParaRPr lang="en-US"/>
           </a:p>
@@ -2727,7 +2734,7 @@
           </a:lstStyle>
           <a:p>
             <a:r>
-              <a:rPr lang="en-US" smtClean="0"/>
+              <a:rPr lang="en-US"/>
               <a:t>Click to edit Master title style</a:t>
             </a:r>
             <a:endParaRPr lang="en-US" dirty="0"/>
@@ -2847,7 +2854,7 @@
           <a:p>
             <a:pPr lvl="0"/>
             <a:r>
-              <a:rPr lang="en-US" smtClean="0"/>
+              <a:rPr lang="en-US"/>
               <a:t>Click to edit Master text styles</a:t>
             </a:r>
           </a:p>
@@ -2870,7 +2877,7 @@
           <a:p>
             <a:fld id="{F4D18BF0-D309-41FF-AA8C-FC2AA1806513}" type="datetimeFigureOut">
               <a:rPr lang="en-US" smtClean="0"/>
-              <a:t>3/5/2026</a:t>
+              <a:t>3/6/2026</a:t>
             </a:fld>
             <a:endParaRPr lang="en-US"/>
           </a:p>
@@ -2994,10 +3001,9 @@
           <a:lstStyle/>
           <a:p>
             <a:r>
-              <a:rPr lang="en-US" smtClean="0"/>
+              <a:rPr lang="en-US"/>
               <a:t>Click to edit Master title style</a:t>
             </a:r>
-            <a:endParaRPr lang="en-US"/>
           </a:p>
         </p:txBody>
       </p:sp>
@@ -3051,35 +3057,35 @@
           <a:p>
             <a:pPr lvl="0"/>
             <a:r>
-              <a:rPr lang="en-US" smtClean="0"/>
+              <a:rPr lang="en-US"/>
               <a:t>Click to edit Master text styles</a:t>
             </a:r>
           </a:p>
           <a:p>
             <a:pPr lvl="1"/>
             <a:r>
-              <a:rPr lang="en-US" smtClean="0"/>
+              <a:rPr lang="en-US"/>
               <a:t>Second level</a:t>
             </a:r>
           </a:p>
           <a:p>
             <a:pPr lvl="2"/>
             <a:r>
-              <a:rPr lang="en-US" smtClean="0"/>
+              <a:rPr lang="en-US"/>
               <a:t>Third level</a:t>
             </a:r>
           </a:p>
           <a:p>
             <a:pPr lvl="3"/>
             <a:r>
-              <a:rPr lang="en-US" smtClean="0"/>
+              <a:rPr lang="en-US"/>
               <a:t>Fourth level</a:t>
             </a:r>
           </a:p>
           <a:p>
             <a:pPr lvl="4"/>
             <a:r>
-              <a:rPr lang="en-US" smtClean="0"/>
+              <a:rPr lang="en-US"/>
               <a:t>Fifth level</a:t>
             </a:r>
             <a:endParaRPr lang="en-US" dirty="0"/>
@@ -3136,35 +3142,35 @@
           <a:p>
             <a:pPr lvl="0"/>
             <a:r>
-              <a:rPr lang="en-US" smtClean="0"/>
+              <a:rPr lang="en-US"/>
               <a:t>Click to edit Master text styles</a:t>
             </a:r>
           </a:p>
           <a:p>
             <a:pPr lvl="1"/>
             <a:r>
-              <a:rPr lang="en-US" smtClean="0"/>
+              <a:rPr lang="en-US"/>
               <a:t>Second level</a:t>
             </a:r>
           </a:p>
           <a:p>
             <a:pPr lvl="2"/>
             <a:r>
-              <a:rPr lang="en-US" smtClean="0"/>
+              <a:rPr lang="en-US"/>
               <a:t>Third level</a:t>
             </a:r>
           </a:p>
           <a:p>
             <a:pPr lvl="3"/>
             <a:r>
-              <a:rPr lang="en-US" smtClean="0"/>
+              <a:rPr lang="en-US"/>
               <a:t>Fourth level</a:t>
             </a:r>
           </a:p>
           <a:p>
             <a:pPr lvl="4"/>
             <a:r>
-              <a:rPr lang="en-US" smtClean="0"/>
+              <a:rPr lang="en-US"/>
               <a:t>Fifth level</a:t>
             </a:r>
             <a:endParaRPr lang="en-US" dirty="0"/>
@@ -3188,7 +3194,7 @@
           <a:p>
             <a:fld id="{F4D18BF0-D309-41FF-AA8C-FC2AA1806513}" type="datetimeFigureOut">
               <a:rPr lang="en-US" smtClean="0"/>
-              <a:t>3/5/2026</a:t>
+              <a:t>3/6/2026</a:t>
             </a:fld>
             <a:endParaRPr lang="en-US"/>
           </a:p>
@@ -3281,7 +3287,7 @@
           </a:lstStyle>
           <a:p>
             <a:r>
-              <a:rPr lang="en-US" smtClean="0"/>
+              <a:rPr lang="en-US"/>
               <a:t>Click to edit Master title style</a:t>
             </a:r>
             <a:endParaRPr lang="en-US" dirty="0"/>
@@ -3370,7 +3376,7 @@
           <a:p>
             <a:pPr lvl="0"/>
             <a:r>
-              <a:rPr lang="en-US" smtClean="0"/>
+              <a:rPr lang="en-US"/>
               <a:t>Click to edit Master text styles</a:t>
             </a:r>
           </a:p>
@@ -3426,35 +3432,35 @@
           <a:p>
             <a:pPr lvl="0"/>
             <a:r>
-              <a:rPr lang="en-US" smtClean="0"/>
+              <a:rPr lang="en-US"/>
               <a:t>Click to edit Master text styles</a:t>
             </a:r>
           </a:p>
           <a:p>
             <a:pPr lvl="1"/>
             <a:r>
-              <a:rPr lang="en-US" smtClean="0"/>
+              <a:rPr lang="en-US"/>
               <a:t>Second level</a:t>
             </a:r>
           </a:p>
           <a:p>
             <a:pPr lvl="2"/>
             <a:r>
-              <a:rPr lang="en-US" smtClean="0"/>
+              <a:rPr lang="en-US"/>
               <a:t>Third level</a:t>
             </a:r>
           </a:p>
           <a:p>
             <a:pPr lvl="3"/>
             <a:r>
-              <a:rPr lang="en-US" smtClean="0"/>
+              <a:rPr lang="en-US"/>
               <a:t>Fourth level</a:t>
             </a:r>
           </a:p>
           <a:p>
             <a:pPr lvl="4"/>
             <a:r>
-              <a:rPr lang="en-US" smtClean="0"/>
+              <a:rPr lang="en-US"/>
               <a:t>Fifth level</a:t>
             </a:r>
             <a:endParaRPr lang="en-US" dirty="0"/>
@@ -3546,7 +3552,7 @@
           <a:p>
             <a:pPr lvl="0"/>
             <a:r>
-              <a:rPr lang="en-US" smtClean="0"/>
+              <a:rPr lang="en-US"/>
               <a:t>Click to edit Master text styles</a:t>
             </a:r>
           </a:p>
@@ -3602,35 +3608,35 @@
           <a:p>
             <a:pPr lvl="0"/>
             <a:r>
-              <a:rPr lang="en-US" smtClean="0"/>
+              <a:rPr lang="en-US"/>
               <a:t>Click to edit Master text styles</a:t>
             </a:r>
           </a:p>
           <a:p>
             <a:pPr lvl="1"/>
             <a:r>
-              <a:rPr lang="en-US" smtClean="0"/>
+              <a:rPr lang="en-US"/>
               <a:t>Second level</a:t>
             </a:r>
           </a:p>
           <a:p>
             <a:pPr lvl="2"/>
             <a:r>
-              <a:rPr lang="en-US" smtClean="0"/>
+              <a:rPr lang="en-US"/>
               <a:t>Third level</a:t>
             </a:r>
           </a:p>
           <a:p>
             <a:pPr lvl="3"/>
             <a:r>
-              <a:rPr lang="en-US" smtClean="0"/>
+              <a:rPr lang="en-US"/>
               <a:t>Fourth level</a:t>
             </a:r>
           </a:p>
           <a:p>
             <a:pPr lvl="4"/>
             <a:r>
-              <a:rPr lang="en-US" smtClean="0"/>
+              <a:rPr lang="en-US"/>
               <a:t>Fifth level</a:t>
             </a:r>
             <a:endParaRPr lang="en-US" dirty="0"/>
@@ -3654,7 +3660,7 @@
           <a:p>
             <a:fld id="{F4D18BF0-D309-41FF-AA8C-FC2AA1806513}" type="datetimeFigureOut">
               <a:rPr lang="en-US" smtClean="0"/>
-              <a:t>3/5/2026</a:t>
+              <a:t>3/6/2026</a:t>
             </a:fld>
             <a:endParaRPr lang="en-US"/>
           </a:p>
@@ -3778,10 +3784,9 @@
           <a:lstStyle/>
           <a:p>
             <a:r>
-              <a:rPr lang="en-US" smtClean="0"/>
+              <a:rPr lang="en-US"/>
               <a:t>Click to edit Master title style</a:t>
             </a:r>
-            <a:endParaRPr lang="en-US"/>
           </a:p>
         </p:txBody>
       </p:sp>
@@ -3802,7 +3807,7 @@
           <a:p>
             <a:fld id="{F4D18BF0-D309-41FF-AA8C-FC2AA1806513}" type="datetimeFigureOut">
               <a:rPr lang="en-US" smtClean="0"/>
-              <a:t>3/5/2026</a:t>
+              <a:t>3/6/2026</a:t>
             </a:fld>
             <a:endParaRPr lang="en-US"/>
           </a:p>
@@ -3892,7 +3897,7 @@
           <a:p>
             <a:fld id="{F4D18BF0-D309-41FF-AA8C-FC2AA1806513}" type="datetimeFigureOut">
               <a:rPr lang="en-US" smtClean="0"/>
-              <a:t>3/5/2026</a:t>
+              <a:t>3/6/2026</a:t>
             </a:fld>
             <a:endParaRPr lang="en-US"/>
           </a:p>
@@ -3992,7 +3997,7 @@
           </a:lstStyle>
           <a:p>
             <a:r>
-              <a:rPr lang="en-US" smtClean="0"/>
+              <a:rPr lang="en-US"/>
               <a:t>Click to edit Master title style</a:t>
             </a:r>
             <a:endParaRPr lang="en-US" dirty="0"/>
@@ -4049,35 +4054,35 @@
           <a:p>
             <a:pPr lvl="0"/>
             <a:r>
-              <a:rPr lang="en-US" smtClean="0"/>
+              <a:rPr lang="en-US"/>
               <a:t>Click to edit Master text styles</a:t>
             </a:r>
           </a:p>
           <a:p>
             <a:pPr lvl="1"/>
             <a:r>
-              <a:rPr lang="en-US" smtClean="0"/>
+              <a:rPr lang="en-US"/>
               <a:t>Second level</a:t>
             </a:r>
           </a:p>
           <a:p>
             <a:pPr lvl="2"/>
             <a:r>
-              <a:rPr lang="en-US" smtClean="0"/>
+              <a:rPr lang="en-US"/>
               <a:t>Third level</a:t>
             </a:r>
           </a:p>
           <a:p>
             <a:pPr lvl="3"/>
             <a:r>
-              <a:rPr lang="en-US" smtClean="0"/>
+              <a:rPr lang="en-US"/>
               <a:t>Fourth level</a:t>
             </a:r>
           </a:p>
           <a:p>
             <a:pPr lvl="4"/>
             <a:r>
-              <a:rPr lang="en-US" smtClean="0"/>
+              <a:rPr lang="en-US"/>
               <a:t>Fifth level</a:t>
             </a:r>
             <a:endParaRPr lang="en-US" dirty="0"/>
@@ -4143,7 +4148,7 @@
           <a:p>
             <a:pPr lvl="0"/>
             <a:r>
-              <a:rPr lang="en-US" smtClean="0"/>
+              <a:rPr lang="en-US"/>
               <a:t>Click to edit Master text styles</a:t>
             </a:r>
           </a:p>
@@ -4166,7 +4171,7 @@
           <a:p>
             <a:fld id="{F4D18BF0-D309-41FF-AA8C-FC2AA1806513}" type="datetimeFigureOut">
               <a:rPr lang="en-US" smtClean="0"/>
-              <a:t>3/5/2026</a:t>
+              <a:t>3/6/2026</a:t>
             </a:fld>
             <a:endParaRPr lang="en-US"/>
           </a:p>
@@ -4301,7 +4306,7 @@
           </a:lstStyle>
           <a:p>
             <a:r>
-              <a:rPr lang="en-US" smtClean="0"/>
+              <a:rPr lang="en-US"/>
               <a:t>Click to edit Master title style</a:t>
             </a:r>
             <a:endParaRPr lang="en-US" dirty="0"/>
@@ -4382,7 +4387,7 @@
           </a:lstStyle>
           <a:p>
             <a:r>
-              <a:rPr lang="en-US" smtClean="0"/>
+              <a:rPr lang="en-US"/>
               <a:t>Click icon to add picture</a:t>
             </a:r>
             <a:endParaRPr lang="en-US" dirty="0"/>
@@ -4448,7 +4453,7 @@
           <a:p>
             <a:pPr lvl="0"/>
             <a:r>
-              <a:rPr lang="en-US" smtClean="0"/>
+              <a:rPr lang="en-US"/>
               <a:t>Click to edit Master text styles</a:t>
             </a:r>
           </a:p>
@@ -4471,7 +4476,7 @@
           <a:p>
             <a:fld id="{F4D18BF0-D309-41FF-AA8C-FC2AA1806513}" type="datetimeFigureOut">
               <a:rPr lang="en-US" smtClean="0"/>
-              <a:t>3/5/2026</a:t>
+              <a:t>3/6/2026</a:t>
             </a:fld>
             <a:endParaRPr lang="en-US"/>
           </a:p>
@@ -4621,7 +4626,7 @@
           <a:lstStyle/>
           <a:p>
             <a:r>
-              <a:rPr lang="en-US" smtClean="0"/>
+              <a:rPr lang="en-US"/>
               <a:t>Click to edit Master title style</a:t>
             </a:r>
             <a:endParaRPr lang="en-US" dirty="0"/>
@@ -4655,35 +4660,35 @@
           <a:p>
             <a:pPr lvl="0"/>
             <a:r>
-              <a:rPr lang="en-US" smtClean="0"/>
+              <a:rPr lang="en-US"/>
               <a:t>Click to edit Master text styles</a:t>
             </a:r>
           </a:p>
           <a:p>
             <a:pPr lvl="1"/>
             <a:r>
-              <a:rPr lang="en-US" smtClean="0"/>
+              <a:rPr lang="en-US"/>
               <a:t>Second level</a:t>
             </a:r>
           </a:p>
           <a:p>
             <a:pPr lvl="2"/>
             <a:r>
-              <a:rPr lang="en-US" smtClean="0"/>
+              <a:rPr lang="en-US"/>
               <a:t>Third level</a:t>
             </a:r>
           </a:p>
           <a:p>
             <a:pPr lvl="3"/>
             <a:r>
-              <a:rPr lang="en-US" smtClean="0"/>
+              <a:rPr lang="en-US"/>
               <a:t>Fourth level</a:t>
             </a:r>
           </a:p>
           <a:p>
             <a:pPr lvl="4"/>
             <a:r>
-              <a:rPr lang="en-US" smtClean="0"/>
+              <a:rPr lang="en-US"/>
               <a:t>Fifth level</a:t>
             </a:r>
             <a:endParaRPr lang="en-US" dirty="0"/>
@@ -4769,7 +4774,7 @@
           <a:p>
             <a:fld id="{F4D18BF0-D309-41FF-AA8C-FC2AA1806513}" type="datetimeFigureOut">
               <a:rPr lang="en-US" smtClean="0"/>
-              <a:t>3/5/2026</a:t>
+              <a:t>3/6/2026</a:t>
             </a:fld>
             <a:endParaRPr lang="en-US"/>
           </a:p>
@@ -5501,7 +5506,7 @@
                 </a:lnSpc>
               </a:pPr>
               <a:r>
-                <a:rPr lang="en-US" sz="8000" b="1" dirty="0" smtClean="0">
+                <a:rPr lang="en-US" sz="8000" b="1" dirty="0">
                   <a:solidFill>
                     <a:srgbClr val="000000"/>
                   </a:solidFill>
@@ -5552,27 +5557,7 @@
                   <a:latin typeface="DM Sans"/>
                   <a:sym typeface="DM Sans"/>
                 </a:rPr>
-                <a:t>How to </a:t>
-              </a:r>
-              <a:r>
-                <a:rPr lang="en-US" sz="4000" b="1" dirty="0" smtClean="0">
-                  <a:solidFill>
-                    <a:srgbClr val="000000"/>
-                  </a:solidFill>
-                  <a:latin typeface="DM Sans"/>
-                  <a:sym typeface="DM Sans"/>
-                </a:rPr>
-                <a:t>address </a:t>
-              </a:r>
-              <a:r>
-                <a:rPr lang="en-US" sz="4000" b="1" dirty="0">
-                  <a:solidFill>
-                    <a:srgbClr val="000000"/>
-                  </a:solidFill>
-                  <a:latin typeface="DM Sans"/>
-                  <a:sym typeface="DM Sans"/>
-                </a:rPr>
-                <a:t>the long-term prevention of stroke risk factors</a:t>
+                <a:t>How to address the long-term prevention of stroke risk factors</a:t>
               </a:r>
               <a:endParaRPr sz="4000" dirty="0"/>
             </a:p>
@@ -5665,7 +5650,7 @@
                 <a:cs typeface="DM Sans"/>
                 <a:sym typeface="DM Sans"/>
               </a:rPr>
-              <a:t>07/17/2023</a:t>
+              <a:t>03/07/2026</a:t>
             </a:r>
             <a:endParaRPr sz="1200" dirty="0"/>
           </a:p>
@@ -5706,13 +5691,6 @@
   <p:clrMapOvr>
     <a:masterClrMapping/>
   </p:clrMapOvr>
-  <p:timing>
-    <p:tnLst>
-      <p:par>
-        <p:cTn id="1" dur="indefinite" restart="never" nodeType="tmRoot"/>
-      </p:par>
-    </p:tnLst>
-  </p:timing>
 </p:sld>
 </file>
 
@@ -5738,7 +5716,7 @@
           <p:cNvPr id="2" name="Title 1">
             <a:extLst>
               <a:ext uri="{FF2B5EF4-FFF2-40B4-BE49-F238E27FC236}">
-                <a16:creationId xmlns:a16="http://schemas.microsoft.com/office/drawing/2014/main" xmlns="" id="{01C10B9E-90C0-9670-DAA4-76A271EAE1C2}"/>
+                <a16:creationId xmlns:a16="http://schemas.microsoft.com/office/drawing/2014/main" id="{01C10B9E-90C0-9670-DAA4-76A271EAE1C2}"/>
               </a:ext>
             </a:extLst>
           </p:cNvPr>
@@ -5776,7 +5754,7 @@
           <p:cNvPr id="7" name="TextBox 6">
             <a:extLst>
               <a:ext uri="{FF2B5EF4-FFF2-40B4-BE49-F238E27FC236}">
-                <a16:creationId xmlns:a16="http://schemas.microsoft.com/office/drawing/2014/main" xmlns="" id="{6B483A5E-4DDA-A3E0-EDFB-D0FF1AA4EAB5}"/>
+                <a16:creationId xmlns:a16="http://schemas.microsoft.com/office/drawing/2014/main" id="{6B483A5E-4DDA-A3E0-EDFB-D0FF1AA4EAB5}"/>
               </a:ext>
             </a:extLst>
           </p:cNvPr>
@@ -5826,7 +5804,7 @@
           <p:cNvPr id="5" name="Picture 4">
             <a:extLst>
               <a:ext uri="{FF2B5EF4-FFF2-40B4-BE49-F238E27FC236}">
-                <a16:creationId xmlns:a16="http://schemas.microsoft.com/office/drawing/2014/main" xmlns="" id="{C75444B8-5D86-E68B-3EBA-EF948AAAA4EC}"/>
+                <a16:creationId xmlns:a16="http://schemas.microsoft.com/office/drawing/2014/main" id="{C75444B8-5D86-E68B-3EBA-EF948AAAA4EC}"/>
               </a:ext>
             </a:extLst>
           </p:cNvPr>
@@ -5862,7 +5840,7 @@
           <p:cNvPr id="9" name="Picture 8">
             <a:extLst>
               <a:ext uri="{FF2B5EF4-FFF2-40B4-BE49-F238E27FC236}">
-                <a16:creationId xmlns:a16="http://schemas.microsoft.com/office/drawing/2014/main" xmlns="" id="{2675BDA9-A3D6-7D87-07BD-09F6863468E0}"/>
+                <a16:creationId xmlns:a16="http://schemas.microsoft.com/office/drawing/2014/main" id="{2675BDA9-A3D6-7D87-07BD-09F6863468E0}"/>
               </a:ext>
             </a:extLst>
           </p:cNvPr>
@@ -5903,13 +5881,6 @@
   <p:clrMapOvr>
     <a:masterClrMapping/>
   </p:clrMapOvr>
-  <p:timing>
-    <p:tnLst>
-      <p:par>
-        <p:cTn id="1" dur="indefinite" restart="never" nodeType="tmRoot"/>
-      </p:par>
-    </p:tnLst>
-  </p:timing>
 </p:sld>
 </file>
 
@@ -5935,7 +5906,7 @@
           <p:cNvPr id="2" name="Title 1">
             <a:extLst>
               <a:ext uri="{FF2B5EF4-FFF2-40B4-BE49-F238E27FC236}">
-                <a16:creationId xmlns:a16="http://schemas.microsoft.com/office/drawing/2014/main" xmlns="" id="{133460DC-725D-68D9-A0E1-CA81CA68E035}"/>
+                <a16:creationId xmlns:a16="http://schemas.microsoft.com/office/drawing/2014/main" id="{133460DC-725D-68D9-A0E1-CA81CA68E035}"/>
               </a:ext>
             </a:extLst>
           </p:cNvPr>
@@ -5973,7 +5944,7 @@
           <p:cNvPr id="4" name="Picture 3">
             <a:extLst>
               <a:ext uri="{FF2B5EF4-FFF2-40B4-BE49-F238E27FC236}">
-                <a16:creationId xmlns:a16="http://schemas.microsoft.com/office/drawing/2014/main" xmlns="" id="{4C074982-224C-F718-2655-1ADD433920F9}"/>
+                <a16:creationId xmlns:a16="http://schemas.microsoft.com/office/drawing/2014/main" id="{4C074982-224C-F718-2655-1ADD433920F9}"/>
               </a:ext>
             </a:extLst>
           </p:cNvPr>
@@ -6009,7 +5980,7 @@
           <p:cNvPr id="6" name="Picture 5">
             <a:extLst>
               <a:ext uri="{FF2B5EF4-FFF2-40B4-BE49-F238E27FC236}">
-                <a16:creationId xmlns:a16="http://schemas.microsoft.com/office/drawing/2014/main" xmlns="" id="{61EDA505-3CDA-18D8-27DB-EA9CCD764CE6}"/>
+                <a16:creationId xmlns:a16="http://schemas.microsoft.com/office/drawing/2014/main" id="{61EDA505-3CDA-18D8-27DB-EA9CCD764CE6}"/>
               </a:ext>
             </a:extLst>
           </p:cNvPr>
@@ -6050,13 +6021,6 @@
   <p:clrMapOvr>
     <a:masterClrMapping/>
   </p:clrMapOvr>
-  <p:timing>
-    <p:tnLst>
-      <p:par>
-        <p:cTn id="1" dur="indefinite" restart="never" nodeType="tmRoot"/>
-      </p:par>
-    </p:tnLst>
-  </p:timing>
 </p:sld>
 </file>
 
@@ -6082,7 +6046,7 @@
           <p:cNvPr id="2" name="Title 1">
             <a:extLst>
               <a:ext uri="{FF2B5EF4-FFF2-40B4-BE49-F238E27FC236}">
-                <a16:creationId xmlns:a16="http://schemas.microsoft.com/office/drawing/2014/main" xmlns="" id="{29C9DFEB-0CA1-CB6C-4AFD-3BC259ED3B9E}"/>
+                <a16:creationId xmlns:a16="http://schemas.microsoft.com/office/drawing/2014/main" id="{29C9DFEB-0CA1-CB6C-4AFD-3BC259ED3B9E}"/>
               </a:ext>
             </a:extLst>
           </p:cNvPr>
@@ -6120,7 +6084,7 @@
           <p:cNvPr id="4" name="Picture 3">
             <a:extLst>
               <a:ext uri="{FF2B5EF4-FFF2-40B4-BE49-F238E27FC236}">
-                <a16:creationId xmlns:a16="http://schemas.microsoft.com/office/drawing/2014/main" xmlns="" id="{534FECA0-84D6-8895-9DCD-7AAC0FE96103}"/>
+                <a16:creationId xmlns:a16="http://schemas.microsoft.com/office/drawing/2014/main" id="{534FECA0-84D6-8895-9DCD-7AAC0FE96103}"/>
               </a:ext>
             </a:extLst>
           </p:cNvPr>
@@ -6156,7 +6120,7 @@
           <p:cNvPr id="6" name="Picture 5">
             <a:extLst>
               <a:ext uri="{FF2B5EF4-FFF2-40B4-BE49-F238E27FC236}">
-                <a16:creationId xmlns:a16="http://schemas.microsoft.com/office/drawing/2014/main" xmlns="" id="{EFE99F0D-6888-2FD5-992A-E287A9783734}"/>
+                <a16:creationId xmlns:a16="http://schemas.microsoft.com/office/drawing/2014/main" id="{EFE99F0D-6888-2FD5-992A-E287A9783734}"/>
               </a:ext>
             </a:extLst>
           </p:cNvPr>
@@ -6197,13 +6161,6 @@
   <p:clrMapOvr>
     <a:masterClrMapping/>
   </p:clrMapOvr>
-  <p:timing>
-    <p:tnLst>
-      <p:par>
-        <p:cTn id="1" dur="indefinite" restart="never" nodeType="tmRoot"/>
-      </p:par>
-    </p:tnLst>
-  </p:timing>
 </p:sld>
 </file>
 
@@ -6215,7 +6172,7 @@
         <p:cNvPr id="1" name="Shape 274">
           <a:extLst>
             <a:ext uri="{FF2B5EF4-FFF2-40B4-BE49-F238E27FC236}">
-              <a16:creationId xmlns:a16="http://schemas.microsoft.com/office/drawing/2014/main" xmlns="" id="{1C30281B-3760-2161-5794-B3B88C1381EC}"/>
+              <a16:creationId xmlns:a16="http://schemas.microsoft.com/office/drawing/2014/main" id="{1C30281B-3760-2161-5794-B3B88C1381EC}"/>
             </a:ext>
           </a:extLst>
         </p:cNvPr>
@@ -6235,7 +6192,7 @@
           <p:cNvPr id="277" name="Google Shape;277;p23">
             <a:extLst>
               <a:ext uri="{FF2B5EF4-FFF2-40B4-BE49-F238E27FC236}">
-                <a16:creationId xmlns:a16="http://schemas.microsoft.com/office/drawing/2014/main" xmlns="" id="{AB0BA0EA-3DF6-19F9-C9DA-6139AA37C04B}"/>
+                <a16:creationId xmlns:a16="http://schemas.microsoft.com/office/drawing/2014/main" id="{AB0BA0EA-3DF6-19F9-C9DA-6139AA37C04B}"/>
               </a:ext>
             </a:extLst>
           </p:cNvPr>
@@ -6267,7 +6224,7 @@
           <p:cNvPr id="278" name="Google Shape;278;p23">
             <a:extLst>
               <a:ext uri="{FF2B5EF4-FFF2-40B4-BE49-F238E27FC236}">
-                <a16:creationId xmlns:a16="http://schemas.microsoft.com/office/drawing/2014/main" xmlns="" id="{BDC5E0E6-5A49-9DBF-73D2-BF8F66CA890E}"/>
+                <a16:creationId xmlns:a16="http://schemas.microsoft.com/office/drawing/2014/main" id="{BDC5E0E6-5A49-9DBF-73D2-BF8F66CA890E}"/>
               </a:ext>
             </a:extLst>
           </p:cNvPr>
@@ -6368,7 +6325,7 @@
           <p:cNvPr id="279" name="Google Shape;279;p23">
             <a:extLst>
               <a:ext uri="{FF2B5EF4-FFF2-40B4-BE49-F238E27FC236}">
-                <a16:creationId xmlns:a16="http://schemas.microsoft.com/office/drawing/2014/main" xmlns="" id="{55D299CF-9DA6-DBEF-7627-FDF69A2D3F0C}"/>
+                <a16:creationId xmlns:a16="http://schemas.microsoft.com/office/drawing/2014/main" id="{55D299CF-9DA6-DBEF-7627-FDF69A2D3F0C}"/>
               </a:ext>
             </a:extLst>
           </p:cNvPr>
@@ -6455,13 +6412,6 @@
   <p:transition>
     <p:push/>
   </p:transition>
-  <p:timing>
-    <p:tnLst>
-      <p:par>
-        <p:cTn id="1" dur="indefinite" restart="never" nodeType="tmRoot"/>
-      </p:par>
-    </p:tnLst>
-  </p:timing>
 </p:sld>
 </file>
 
@@ -6487,7 +6437,7 @@
           <p:cNvPr id="2" name="Title 1">
             <a:extLst>
               <a:ext uri="{FF2B5EF4-FFF2-40B4-BE49-F238E27FC236}">
-                <a16:creationId xmlns:a16="http://schemas.microsoft.com/office/drawing/2014/main" xmlns="" id="{504E5768-5196-E7B0-5832-1C34EADE2A9E}"/>
+                <a16:creationId xmlns:a16="http://schemas.microsoft.com/office/drawing/2014/main" id="{504E5768-5196-E7B0-5832-1C34EADE2A9E}"/>
               </a:ext>
             </a:extLst>
           </p:cNvPr>
@@ -6525,7 +6475,7 @@
           <p:cNvPr id="4" name="Picture 3">
             <a:extLst>
               <a:ext uri="{FF2B5EF4-FFF2-40B4-BE49-F238E27FC236}">
-                <a16:creationId xmlns:a16="http://schemas.microsoft.com/office/drawing/2014/main" xmlns="" id="{6E8ED54E-6A0F-3791-032C-7B6A9F60D7D7}"/>
+                <a16:creationId xmlns:a16="http://schemas.microsoft.com/office/drawing/2014/main" id="{6E8ED54E-6A0F-3791-032C-7B6A9F60D7D7}"/>
               </a:ext>
             </a:extLst>
           </p:cNvPr>
@@ -6566,13 +6516,6 @@
   <p:clrMapOvr>
     <a:masterClrMapping/>
   </p:clrMapOvr>
-  <p:timing>
-    <p:tnLst>
-      <p:par>
-        <p:cTn id="1" dur="indefinite" restart="never" nodeType="tmRoot"/>
-      </p:par>
-    </p:tnLst>
-  </p:timing>
 </p:sld>
 </file>
 
@@ -6598,7 +6541,7 @@
           <p:cNvPr id="2" name="Title 1">
             <a:extLst>
               <a:ext uri="{FF2B5EF4-FFF2-40B4-BE49-F238E27FC236}">
-                <a16:creationId xmlns:a16="http://schemas.microsoft.com/office/drawing/2014/main" xmlns="" id="{1FE84273-F5F3-6139-2570-575B7D985726}"/>
+                <a16:creationId xmlns:a16="http://schemas.microsoft.com/office/drawing/2014/main" id="{1FE84273-F5F3-6139-2570-575B7D985726}"/>
               </a:ext>
             </a:extLst>
           </p:cNvPr>
@@ -6636,7 +6579,7 @@
           <p:cNvPr id="5" name="Picture 4">
             <a:extLst>
               <a:ext uri="{FF2B5EF4-FFF2-40B4-BE49-F238E27FC236}">
-                <a16:creationId xmlns:a16="http://schemas.microsoft.com/office/drawing/2014/main" xmlns="" id="{72207C6A-CBC3-B195-4FA4-064B4BCEDF82}"/>
+                <a16:creationId xmlns:a16="http://schemas.microsoft.com/office/drawing/2014/main" id="{72207C6A-CBC3-B195-4FA4-064B4BCEDF82}"/>
               </a:ext>
             </a:extLst>
           </p:cNvPr>
@@ -6677,13 +6620,6 @@
   <p:clrMapOvr>
     <a:masterClrMapping/>
   </p:clrMapOvr>
-  <p:timing>
-    <p:tnLst>
-      <p:par>
-        <p:cTn id="1" dur="indefinite" restart="never" nodeType="tmRoot"/>
-      </p:par>
-    </p:tnLst>
-  </p:timing>
 </p:sld>
 </file>
 
@@ -6709,7 +6645,7 @@
           <p:cNvPr id="7" name="TextBox 6">
             <a:extLst>
               <a:ext uri="{FF2B5EF4-FFF2-40B4-BE49-F238E27FC236}">
-                <a16:creationId xmlns:a16="http://schemas.microsoft.com/office/drawing/2014/main" xmlns="" id="{613E3048-8AB0-6339-1911-14C3BD8B35D9}"/>
+                <a16:creationId xmlns:a16="http://schemas.microsoft.com/office/drawing/2014/main" id="{613E3048-8AB0-6339-1911-14C3BD8B35D9}"/>
               </a:ext>
             </a:extLst>
           </p:cNvPr>
@@ -6758,7 +6694,7 @@
           <p:cNvPr id="11" name="Picture 10">
             <a:extLst>
               <a:ext uri="{FF2B5EF4-FFF2-40B4-BE49-F238E27FC236}">
-                <a16:creationId xmlns:a16="http://schemas.microsoft.com/office/drawing/2014/main" xmlns="" id="{DC5116E7-9696-4B20-3D8A-0031F5B899A7}"/>
+                <a16:creationId xmlns:a16="http://schemas.microsoft.com/office/drawing/2014/main" id="{DC5116E7-9696-4B20-3D8A-0031F5B899A7}"/>
               </a:ext>
             </a:extLst>
           </p:cNvPr>
@@ -6794,7 +6730,7 @@
           <p:cNvPr id="6" name="Title 5">
             <a:extLst>
               <a:ext uri="{FF2B5EF4-FFF2-40B4-BE49-F238E27FC236}">
-                <a16:creationId xmlns:a16="http://schemas.microsoft.com/office/drawing/2014/main" xmlns="" id="{425BEFA8-7ED3-BA25-9651-0FE3544DB1D9}"/>
+                <a16:creationId xmlns:a16="http://schemas.microsoft.com/office/drawing/2014/main" id="{425BEFA8-7ED3-BA25-9651-0FE3544DB1D9}"/>
               </a:ext>
             </a:extLst>
           </p:cNvPr>
@@ -6885,7 +6821,7 @@
           <p:cNvPr id="3" name="Title 1">
             <a:extLst>
               <a:ext uri="{FF2B5EF4-FFF2-40B4-BE49-F238E27FC236}">
-                <a16:creationId xmlns:a16="http://schemas.microsoft.com/office/drawing/2014/main" xmlns="" id="{D2A1B674-38BE-4390-2336-69EDE0FC8E51}"/>
+                <a16:creationId xmlns:a16="http://schemas.microsoft.com/office/drawing/2014/main" id="{D2A1B674-38BE-4390-2336-69EDE0FC8E51}"/>
               </a:ext>
             </a:extLst>
           </p:cNvPr>
@@ -6936,7 +6872,7 @@
           <p:cNvPr id="4" name="Title 1">
             <a:extLst>
               <a:ext uri="{FF2B5EF4-FFF2-40B4-BE49-F238E27FC236}">
-                <a16:creationId xmlns:a16="http://schemas.microsoft.com/office/drawing/2014/main" xmlns="" id="{DEE56EF2-EB15-BDB8-F898-3303C9BB23AB}"/>
+                <a16:creationId xmlns:a16="http://schemas.microsoft.com/office/drawing/2014/main" id="{DEE56EF2-EB15-BDB8-F898-3303C9BB23AB}"/>
               </a:ext>
             </a:extLst>
           </p:cNvPr>
@@ -7000,7 +6936,7 @@
           <p:cNvPr id="6" name="Picture 5">
             <a:extLst>
               <a:ext uri="{FF2B5EF4-FFF2-40B4-BE49-F238E27FC236}">
-                <a16:creationId xmlns:a16="http://schemas.microsoft.com/office/drawing/2014/main" xmlns="" id="{31ED442E-E669-5E39-BCAF-17EC948309F2}"/>
+                <a16:creationId xmlns:a16="http://schemas.microsoft.com/office/drawing/2014/main" id="{31ED442E-E669-5E39-BCAF-17EC948309F2}"/>
               </a:ext>
             </a:extLst>
           </p:cNvPr>
@@ -7036,7 +6972,7 @@
           <p:cNvPr id="2" name="Title 1">
             <a:extLst>
               <a:ext uri="{FF2B5EF4-FFF2-40B4-BE49-F238E27FC236}">
-                <a16:creationId xmlns:a16="http://schemas.microsoft.com/office/drawing/2014/main" xmlns="" id="{80E1CF65-26FA-FE28-1A72-ABF074E7E04B}"/>
+                <a16:creationId xmlns:a16="http://schemas.microsoft.com/office/drawing/2014/main" id="{80E1CF65-26FA-FE28-1A72-ABF074E7E04B}"/>
               </a:ext>
             </a:extLst>
           </p:cNvPr>
@@ -7128,7 +7064,7 @@
           <p:cNvPr id="2" name="Title 1">
             <a:extLst>
               <a:ext uri="{FF2B5EF4-FFF2-40B4-BE49-F238E27FC236}">
-                <a16:creationId xmlns:a16="http://schemas.microsoft.com/office/drawing/2014/main" xmlns="" id="{B0691AED-5067-823A-C7CB-1DA20B2CFADC}"/>
+                <a16:creationId xmlns:a16="http://schemas.microsoft.com/office/drawing/2014/main" id="{B0691AED-5067-823A-C7CB-1DA20B2CFADC}"/>
               </a:ext>
             </a:extLst>
           </p:cNvPr>
@@ -7188,7 +7124,7 @@
           <p:cNvPr id="4" name="Picture 3">
             <a:extLst>
               <a:ext uri="{FF2B5EF4-FFF2-40B4-BE49-F238E27FC236}">
-                <a16:creationId xmlns:a16="http://schemas.microsoft.com/office/drawing/2014/main" xmlns="" id="{7A8D01C5-4D40-835B-212D-C7A937F37951}"/>
+                <a16:creationId xmlns:a16="http://schemas.microsoft.com/office/drawing/2014/main" id="{7A8D01C5-4D40-835B-212D-C7A937F37951}"/>
               </a:ext>
             </a:extLst>
           </p:cNvPr>
@@ -7240,7 +7176,7 @@
         <p:cNvPr id="1" name="">
           <a:extLst>
             <a:ext uri="{FF2B5EF4-FFF2-40B4-BE49-F238E27FC236}">
-              <a16:creationId xmlns:a16="http://schemas.microsoft.com/office/drawing/2014/main" xmlns="" id="{CF63FAAA-A097-0BF1-BF9D-904760525EAE}"/>
+              <a16:creationId xmlns:a16="http://schemas.microsoft.com/office/drawing/2014/main" id="{CF63FAAA-A097-0BF1-BF9D-904760525EAE}"/>
             </a:ext>
           </a:extLst>
         </p:cNvPr>
@@ -7260,7 +7196,7 @@
           <p:cNvPr id="2" name="Title 1">
             <a:extLst>
               <a:ext uri="{FF2B5EF4-FFF2-40B4-BE49-F238E27FC236}">
-                <a16:creationId xmlns:a16="http://schemas.microsoft.com/office/drawing/2014/main" xmlns="" id="{768FF90E-7972-2B4C-8068-BE58D8C6546B}"/>
+                <a16:creationId xmlns:a16="http://schemas.microsoft.com/office/drawing/2014/main" id="{768FF90E-7972-2B4C-8068-BE58D8C6546B}"/>
               </a:ext>
             </a:extLst>
           </p:cNvPr>
@@ -7320,7 +7256,7 @@
           <p:cNvPr id="5" name="Picture 4">
             <a:extLst>
               <a:ext uri="{FF2B5EF4-FFF2-40B4-BE49-F238E27FC236}">
-                <a16:creationId xmlns:a16="http://schemas.microsoft.com/office/drawing/2014/main" xmlns="" id="{271D4B84-3D01-1E10-2DB1-50CD84540A59}"/>
+                <a16:creationId xmlns:a16="http://schemas.microsoft.com/office/drawing/2014/main" id="{271D4B84-3D01-1E10-2DB1-50CD84540A59}"/>
               </a:ext>
             </a:extLst>
           </p:cNvPr>
@@ -7548,13 +7484,6 @@
   <p:transition>
     <p:push/>
   </p:transition>
-  <p:timing>
-    <p:tnLst>
-      <p:par>
-        <p:cTn id="1" dur="indefinite" restart="never" nodeType="tmRoot"/>
-      </p:par>
-    </p:tnLst>
-  </p:timing>
 </p:sld>
 </file>
 
@@ -7566,7 +7495,7 @@
         <p:cNvPr id="1" name="Shape 274">
           <a:extLst>
             <a:ext uri="{FF2B5EF4-FFF2-40B4-BE49-F238E27FC236}">
-              <a16:creationId xmlns:a16="http://schemas.microsoft.com/office/drawing/2014/main" xmlns="" id="{BE34003F-B0E4-9D99-7E7E-4FCB8AECCB15}"/>
+              <a16:creationId xmlns:a16="http://schemas.microsoft.com/office/drawing/2014/main" id="{BE34003F-B0E4-9D99-7E7E-4FCB8AECCB15}"/>
             </a:ext>
           </a:extLst>
         </p:cNvPr>
@@ -7586,7 +7515,7 @@
           <p:cNvPr id="277" name="Google Shape;277;p23">
             <a:extLst>
               <a:ext uri="{FF2B5EF4-FFF2-40B4-BE49-F238E27FC236}">
-                <a16:creationId xmlns:a16="http://schemas.microsoft.com/office/drawing/2014/main" xmlns="" id="{48FA03B2-BA79-B513-672B-F678ADE015B9}"/>
+                <a16:creationId xmlns:a16="http://schemas.microsoft.com/office/drawing/2014/main" id="{48FA03B2-BA79-B513-672B-F678ADE015B9}"/>
               </a:ext>
             </a:extLst>
           </p:cNvPr>
@@ -7618,7 +7547,7 @@
           <p:cNvPr id="278" name="Google Shape;278;p23">
             <a:extLst>
               <a:ext uri="{FF2B5EF4-FFF2-40B4-BE49-F238E27FC236}">
-                <a16:creationId xmlns:a16="http://schemas.microsoft.com/office/drawing/2014/main" xmlns="" id="{3E731076-B7A8-BFFC-339F-72BC223F4891}"/>
+                <a16:creationId xmlns:a16="http://schemas.microsoft.com/office/drawing/2014/main" id="{3E731076-B7A8-BFFC-339F-72BC223F4891}"/>
               </a:ext>
             </a:extLst>
           </p:cNvPr>
@@ -7673,7 +7602,7 @@
           <p:cNvPr id="279" name="Google Shape;279;p23">
             <a:extLst>
               <a:ext uri="{FF2B5EF4-FFF2-40B4-BE49-F238E27FC236}">
-                <a16:creationId xmlns:a16="http://schemas.microsoft.com/office/drawing/2014/main" xmlns="" id="{00DCE89C-87BE-BCD7-0E48-058C585160B9}"/>
+                <a16:creationId xmlns:a16="http://schemas.microsoft.com/office/drawing/2014/main" id="{00DCE89C-87BE-BCD7-0E48-058C585160B9}"/>
               </a:ext>
             </a:extLst>
           </p:cNvPr>
@@ -8079,7 +8008,7 @@
         <p:cNvPr id="1" name="Shape 274">
           <a:extLst>
             <a:ext uri="{FF2B5EF4-FFF2-40B4-BE49-F238E27FC236}">
-              <a16:creationId xmlns:a16="http://schemas.microsoft.com/office/drawing/2014/main" xmlns="" id="{8B31EF99-0A3C-FDBB-32CF-EA2C40AA6787}"/>
+              <a16:creationId xmlns:a16="http://schemas.microsoft.com/office/drawing/2014/main" id="{8B31EF99-0A3C-FDBB-32CF-EA2C40AA6787}"/>
             </a:ext>
           </a:extLst>
         </p:cNvPr>
@@ -8099,7 +8028,7 @@
           <p:cNvPr id="278" name="Google Shape;278;p23">
             <a:extLst>
               <a:ext uri="{FF2B5EF4-FFF2-40B4-BE49-F238E27FC236}">
-                <a16:creationId xmlns:a16="http://schemas.microsoft.com/office/drawing/2014/main" xmlns="" id="{D1BB4620-696B-D377-D1DF-6F1382F0C288}"/>
+                <a16:creationId xmlns:a16="http://schemas.microsoft.com/office/drawing/2014/main" id="{D1BB4620-696B-D377-D1DF-6F1382F0C288}"/>
               </a:ext>
             </a:extLst>
           </p:cNvPr>
@@ -8154,7 +8083,7 @@
           <p:cNvPr id="279" name="Google Shape;279;p23">
             <a:extLst>
               <a:ext uri="{FF2B5EF4-FFF2-40B4-BE49-F238E27FC236}">
-                <a16:creationId xmlns:a16="http://schemas.microsoft.com/office/drawing/2014/main" xmlns="" id="{0AF21EBD-1FDC-2D2F-FBB8-D370362333AC}"/>
+                <a16:creationId xmlns:a16="http://schemas.microsoft.com/office/drawing/2014/main" id="{0AF21EBD-1FDC-2D2F-FBB8-D370362333AC}"/>
               </a:ext>
             </a:extLst>
           </p:cNvPr>
@@ -8186,23 +8115,7 @@
             </a:pPr>
             <a:r>
               <a:rPr lang="en-US" sz="3000" dirty="0"/>
-              <a:t>Identify the top </a:t>
-            </a:r>
-            <a:r>
-              <a:rPr lang="en-US" sz="3000" dirty="0" smtClean="0"/>
-              <a:t>3 predictors </a:t>
-            </a:r>
-            <a:r>
-              <a:rPr lang="en-US" sz="3000" dirty="0"/>
-              <a:t>of stroke risk </a:t>
-            </a:r>
-            <a:r>
-              <a:rPr lang="en-US" sz="3000" dirty="0" smtClean="0"/>
-              <a:t>from the dataset and </a:t>
-            </a:r>
-            <a:r>
-              <a:rPr lang="en-US" sz="3000" dirty="0"/>
-              <a:t>determine whether they are primarily lifestyle-based or health-based factors.</a:t>
+              <a:t>Identify the top 3 predictors of stroke risk from the dataset and determine whether they are primarily lifestyle-based or health-based factors.</a:t>
             </a:r>
           </a:p>
           <a:p>
@@ -8240,13 +8153,6 @@
   <p:transition>
     <p:push/>
   </p:transition>
-  <p:timing>
-    <p:tnLst>
-      <p:par>
-        <p:cTn id="1" dur="indefinite" restart="never" nodeType="tmRoot"/>
-      </p:par>
-    </p:tnLst>
-  </p:timing>
 </p:sld>
 </file>
 
@@ -8258,7 +8164,7 @@
         <p:cNvPr id="1" name="Shape 274">
           <a:extLst>
             <a:ext uri="{FF2B5EF4-FFF2-40B4-BE49-F238E27FC236}">
-              <a16:creationId xmlns:a16="http://schemas.microsoft.com/office/drawing/2014/main" xmlns="" id="{8B31EF99-0A3C-FDBB-32CF-EA2C40AA6787}"/>
+              <a16:creationId xmlns:a16="http://schemas.microsoft.com/office/drawing/2014/main" id="{8B31EF99-0A3C-FDBB-32CF-EA2C40AA6787}"/>
             </a:ext>
           </a:extLst>
         </p:cNvPr>
@@ -8278,7 +8184,7 @@
           <p:cNvPr id="278" name="Google Shape;278;p23">
             <a:extLst>
               <a:ext uri="{FF2B5EF4-FFF2-40B4-BE49-F238E27FC236}">
-                <a16:creationId xmlns:a16="http://schemas.microsoft.com/office/drawing/2014/main" xmlns="" id="{D1BB4620-696B-D377-D1DF-6F1382F0C288}"/>
+                <a16:creationId xmlns:a16="http://schemas.microsoft.com/office/drawing/2014/main" id="{D1BB4620-696B-D377-D1DF-6F1382F0C288}"/>
               </a:ext>
             </a:extLst>
           </p:cNvPr>
@@ -8317,27 +8223,7 @@
                 <a:latin typeface="DM Sans"/>
                 <a:sym typeface="DM Sans"/>
               </a:rPr>
-              <a:t>The </a:t>
-            </a:r>
-            <a:r>
-              <a:rPr lang="en-US" sz="4800" b="1" spc="-100" dirty="0">
-                <a:solidFill>
-                  <a:srgbClr val="000000"/>
-                </a:solidFill>
-                <a:latin typeface="DM Sans"/>
-                <a:sym typeface="DM Sans"/>
-              </a:rPr>
-              <a:t>Problem</a:t>
-            </a:r>
-            <a:r>
-              <a:rPr lang="en-US" sz="4800" b="1" spc="-100" dirty="0">
-                <a:solidFill>
-                  <a:srgbClr val="000000"/>
-                </a:solidFill>
-                <a:latin typeface="DM Sans"/>
-                <a:sym typeface="DM Sans"/>
-              </a:rPr>
-              <a:t> to Tackle</a:t>
+              <a:t>The Problem to Tackle</a:t>
             </a:r>
             <a:endParaRPr sz="4800" b="1" spc="-100" dirty="0">
               <a:solidFill>
@@ -8353,7 +8239,7 @@
           <p:cNvPr id="279" name="Google Shape;279;p23">
             <a:extLst>
               <a:ext uri="{FF2B5EF4-FFF2-40B4-BE49-F238E27FC236}">
-                <a16:creationId xmlns:a16="http://schemas.microsoft.com/office/drawing/2014/main" xmlns="" id="{0AF21EBD-1FDC-2D2F-FBB8-D370362333AC}"/>
+                <a16:creationId xmlns:a16="http://schemas.microsoft.com/office/drawing/2014/main" id="{0AF21EBD-1FDC-2D2F-FBB8-D370362333AC}"/>
               </a:ext>
             </a:extLst>
           </p:cNvPr>
@@ -8385,13 +8271,8 @@
             </a:pPr>
             <a:r>
               <a:rPr lang="en-US" sz="3200" dirty="0"/>
-              <a:t>Stroke is a major global health burden, ranking as the 3rd leading cause of disability and </a:t>
-            </a:r>
-            <a:r>
-              <a:rPr lang="en-US" sz="3200" dirty="0" smtClean="0"/>
-              <a:t>mortality.</a:t>
-            </a:r>
-            <a:endParaRPr lang="en-US" sz="3200" dirty="0"/>
+              <a:t>Stroke is a major global health burden, ranking as the 3rd leading cause of disability and mortality.</a:t>
+            </a:r>
           </a:p>
           <a:p>
             <a:pPr marL="457200" indent="-457200">
@@ -8400,11 +8281,7 @@
             </a:pPr>
             <a:r>
               <a:rPr lang="en-US" sz="3200" dirty="0"/>
-              <a:t>High economic impact: In Canada, average 1-year stroke costs exceed $33,000 per </a:t>
-            </a:r>
-            <a:r>
-              <a:rPr lang="en-US" sz="3200" dirty="0" smtClean="0"/>
-              <a:t>patient</a:t>
+              <a:t>High economic impact: In Canada, average 1-year stroke costs exceed $33,000 per patient</a:t>
             </a:r>
           </a:p>
           <a:p>
@@ -8413,44 +8290,8 @@
               <a:buChar char="•"/>
             </a:pPr>
             <a:r>
-              <a:rPr lang="en-US" sz="3200" dirty="0" smtClean="0"/>
-              <a:t>Prevention </a:t>
-            </a:r>
-            <a:r>
               <a:rPr lang="en-US" sz="3200" dirty="0"/>
-              <a:t>gap: </a:t>
-            </a:r>
-            <a:r>
-              <a:rPr lang="en-US" sz="3200" dirty="0" smtClean="0"/>
-              <a:t>Preventive </a:t>
-            </a:r>
-            <a:r>
-              <a:rPr lang="en-US" sz="3200" dirty="0"/>
-              <a:t>care is more effective and less costly than reactive </a:t>
-            </a:r>
-            <a:r>
-              <a:rPr lang="en-US" sz="3200" dirty="0" smtClean="0"/>
-              <a:t>treatment. </a:t>
-            </a:r>
-            <a:r>
-              <a:rPr lang="en-US" sz="3200" dirty="0"/>
-              <a:t>L</a:t>
-            </a:r>
-            <a:r>
-              <a:rPr lang="en-US" sz="3200" dirty="0" smtClean="0"/>
-              <a:t>arge </a:t>
-            </a:r>
-            <a:r>
-              <a:rPr lang="en-US" sz="3200" dirty="0"/>
-              <a:t>amounts of data, </a:t>
-            </a:r>
-            <a:r>
-              <a:rPr lang="en-US" sz="3200" dirty="0" smtClean="0"/>
-              <a:t>make it </a:t>
-            </a:r>
-            <a:r>
-              <a:rPr lang="en-US" sz="3200" dirty="0"/>
-              <a:t>difficult to identify the most critical risk factors to target</a:t>
+              <a:t>Prevention gap: Preventive care is more effective and less costly than reactive treatment. Large amounts of data, make it difficult to identify the most critical risk factors to target</a:t>
             </a:r>
             <a:r>
               <a:rPr lang="en-US" sz="3200" b="1" dirty="0"/>
@@ -8473,13 +8314,6 @@
   <p:transition>
     <p:push/>
   </p:transition>
-  <p:timing>
-    <p:tnLst>
-      <p:par>
-        <p:cTn id="1" dur="indefinite" restart="never" nodeType="tmRoot"/>
-      </p:par>
-    </p:tnLst>
-  </p:timing>
 </p:sld>
 </file>
 
@@ -8553,7 +8387,7 @@
           <p:cNvPr id="2" name="Picture 1">
             <a:extLst>
               <a:ext uri="{FF2B5EF4-FFF2-40B4-BE49-F238E27FC236}">
-                <a16:creationId xmlns:a16="http://schemas.microsoft.com/office/drawing/2014/main" xmlns="" id="{71A07D56-E8C5-9FF7-C661-6D8888A99021}"/>
+                <a16:creationId xmlns:a16="http://schemas.microsoft.com/office/drawing/2014/main" id="{71A07D56-E8C5-9FF7-C661-6D8888A99021}"/>
               </a:ext>
             </a:extLst>
           </p:cNvPr>
@@ -8594,7 +8428,7 @@
           <p:cNvPr id="3" name="TextBox 2">
             <a:extLst>
               <a:ext uri="{FF2B5EF4-FFF2-40B4-BE49-F238E27FC236}">
-                <a16:creationId xmlns:a16="http://schemas.microsoft.com/office/drawing/2014/main" xmlns="" id="{AD85F488-7E4C-8F44-ED85-A8704FF7952D}"/>
+                <a16:creationId xmlns:a16="http://schemas.microsoft.com/office/drawing/2014/main" id="{AD85F488-7E4C-8F44-ED85-A8704FF7952D}"/>
               </a:ext>
             </a:extLst>
           </p:cNvPr>
@@ -8641,7 +8475,7 @@
           <p:cNvPr id="4" name="TextBox 3">
             <a:extLst>
               <a:ext uri="{FF2B5EF4-FFF2-40B4-BE49-F238E27FC236}">
-                <a16:creationId xmlns:a16="http://schemas.microsoft.com/office/drawing/2014/main" xmlns="" id="{C590DB31-32DA-7922-B217-9A1505A0685E}"/>
+                <a16:creationId xmlns:a16="http://schemas.microsoft.com/office/drawing/2014/main" id="{C590DB31-32DA-7922-B217-9A1505A0685E}"/>
               </a:ext>
             </a:extLst>
           </p:cNvPr>
@@ -8665,7 +8499,7 @@
           <a:lstStyle/>
           <a:p>
             <a:r>
-              <a:rPr lang="en-US" dirty="0" smtClean="0"/>
+              <a:rPr lang="en-US" dirty="0"/>
               <a:t>Takeaways: </a:t>
             </a:r>
           </a:p>
@@ -8675,12 +8509,8 @@
               <a:buChar char="•"/>
             </a:pPr>
             <a:r>
-              <a:rPr lang="en-US" dirty="0" smtClean="0"/>
-              <a:t>The </a:t>
-            </a:r>
-            <a:r>
               <a:rPr lang="en-US" dirty="0"/>
-              <a:t>dataset is highly imbalanced (5% positive class)</a:t>
+              <a:t>The dataset is highly imbalanced (5% positive class)</a:t>
             </a:r>
           </a:p>
         </p:txBody>
@@ -8693,13 +8523,6 @@
   <p:transition>
     <p:push/>
   </p:transition>
-  <p:timing>
-    <p:tnLst>
-      <p:par>
-        <p:cTn id="1" dur="indefinite" restart="never" nodeType="tmRoot"/>
-      </p:par>
-    </p:tnLst>
-  </p:timing>
 </p:sld>
 </file>
 
@@ -8817,7 +8640,7 @@
           <p:cNvPr id="2" name="Picture 1">
             <a:extLst>
               <a:ext uri="{FF2B5EF4-FFF2-40B4-BE49-F238E27FC236}">
-                <a16:creationId xmlns:a16="http://schemas.microsoft.com/office/drawing/2014/main" xmlns="" id="{3013F98F-F016-44BD-F010-15306E3E37AC}"/>
+                <a16:creationId xmlns:a16="http://schemas.microsoft.com/office/drawing/2014/main" id="{3013F98F-F016-44BD-F010-15306E3E37AC}"/>
               </a:ext>
             </a:extLst>
           </p:cNvPr>
@@ -8859,7 +8682,7 @@
           <p:cNvPr id="3" name="TextBox 2">
             <a:extLst>
               <a:ext uri="{FF2B5EF4-FFF2-40B4-BE49-F238E27FC236}">
-                <a16:creationId xmlns:a16="http://schemas.microsoft.com/office/drawing/2014/main" xmlns="" id="{4D96EB63-2418-7F70-8C36-AF98EA97CC75}"/>
+                <a16:creationId xmlns:a16="http://schemas.microsoft.com/office/drawing/2014/main" id="{4D96EB63-2418-7F70-8C36-AF98EA97CC75}"/>
               </a:ext>
             </a:extLst>
           </p:cNvPr>
@@ -8911,13 +8734,6 @@
   <p:transition>
     <p:push/>
   </p:transition>
-  <p:timing>
-    <p:tnLst>
-      <p:par>
-        <p:cTn id="1" dur="indefinite" restart="never" nodeType="tmRoot"/>
-      </p:par>
-    </p:tnLst>
-  </p:timing>
 </p:sld>
 </file>
 
@@ -8929,7 +8745,7 @@
         <p:cNvPr id="1" name="Shape 263">
           <a:extLst>
             <a:ext uri="{FF2B5EF4-FFF2-40B4-BE49-F238E27FC236}">
-              <a16:creationId xmlns:a16="http://schemas.microsoft.com/office/drawing/2014/main" xmlns="" id="{947DD4A1-7A93-C10E-5A07-4EC5C681639F}"/>
+              <a16:creationId xmlns:a16="http://schemas.microsoft.com/office/drawing/2014/main" id="{947DD4A1-7A93-C10E-5A07-4EC5C681639F}"/>
             </a:ext>
           </a:extLst>
         </p:cNvPr>
@@ -8949,7 +8765,7 @@
           <p:cNvPr id="266" name="Google Shape;266;p22">
             <a:extLst>
               <a:ext uri="{FF2B5EF4-FFF2-40B4-BE49-F238E27FC236}">
-                <a16:creationId xmlns:a16="http://schemas.microsoft.com/office/drawing/2014/main" xmlns="" id="{4720075E-3549-58CE-84BB-F4BF021C35F2}"/>
+                <a16:creationId xmlns:a16="http://schemas.microsoft.com/office/drawing/2014/main" id="{4720075E-3549-58CE-84BB-F4BF021C35F2}"/>
               </a:ext>
             </a:extLst>
           </p:cNvPr>
@@ -8981,7 +8797,7 @@
           <p:cNvPr id="267" name="Google Shape;267;p22">
             <a:extLst>
               <a:ext uri="{FF2B5EF4-FFF2-40B4-BE49-F238E27FC236}">
-                <a16:creationId xmlns:a16="http://schemas.microsoft.com/office/drawing/2014/main" xmlns="" id="{60A48628-491D-52BC-6A6C-51D0ABB32F30}"/>
+                <a16:creationId xmlns:a16="http://schemas.microsoft.com/office/drawing/2014/main" id="{60A48628-491D-52BC-6A6C-51D0ABB32F30}"/>
               </a:ext>
             </a:extLst>
           </p:cNvPr>
@@ -9013,7 +8829,7 @@
           <p:cNvPr id="268" name="Google Shape;268;p22">
             <a:extLst>
               <a:ext uri="{FF2B5EF4-FFF2-40B4-BE49-F238E27FC236}">
-                <a16:creationId xmlns:a16="http://schemas.microsoft.com/office/drawing/2014/main" xmlns="" id="{2C79D34E-94D8-D801-ABDE-B73F1E41CFCB}"/>
+                <a16:creationId xmlns:a16="http://schemas.microsoft.com/office/drawing/2014/main" id="{2C79D34E-94D8-D801-ABDE-B73F1E41CFCB}"/>
               </a:ext>
             </a:extLst>
           </p:cNvPr>
@@ -9067,7 +8883,7 @@
           <p:cNvPr id="5" name="Picture 4">
             <a:extLst>
               <a:ext uri="{FF2B5EF4-FFF2-40B4-BE49-F238E27FC236}">
-                <a16:creationId xmlns:a16="http://schemas.microsoft.com/office/drawing/2014/main" xmlns="" id="{B6F19372-0553-7137-2291-67799FF3C010}"/>
+                <a16:creationId xmlns:a16="http://schemas.microsoft.com/office/drawing/2014/main" id="{B6F19372-0553-7137-2291-67799FF3C010}"/>
               </a:ext>
             </a:extLst>
           </p:cNvPr>
@@ -9108,7 +8924,7 @@
           <p:cNvPr id="6" name="Picture 5">
             <a:extLst>
               <a:ext uri="{FF2B5EF4-FFF2-40B4-BE49-F238E27FC236}">
-                <a16:creationId xmlns:a16="http://schemas.microsoft.com/office/drawing/2014/main" xmlns="" id="{BF2D48C9-B9D9-3D2B-9218-FC264F29C9D4}"/>
+                <a16:creationId xmlns:a16="http://schemas.microsoft.com/office/drawing/2014/main" id="{BF2D48C9-B9D9-3D2B-9218-FC264F29C9D4}"/>
               </a:ext>
             </a:extLst>
           </p:cNvPr>
@@ -9149,7 +8965,7 @@
           <p:cNvPr id="7" name="Picture 6">
             <a:extLst>
               <a:ext uri="{FF2B5EF4-FFF2-40B4-BE49-F238E27FC236}">
-                <a16:creationId xmlns:a16="http://schemas.microsoft.com/office/drawing/2014/main" xmlns="" id="{0B9634D9-7FC0-117B-8A62-3B88358535A7}"/>
+                <a16:creationId xmlns:a16="http://schemas.microsoft.com/office/drawing/2014/main" id="{0B9634D9-7FC0-117B-8A62-3B88358535A7}"/>
               </a:ext>
             </a:extLst>
           </p:cNvPr>
@@ -9198,13 +9014,6 @@
   <p:transition>
     <p:push/>
   </p:transition>
-  <p:timing>
-    <p:tnLst>
-      <p:par>
-        <p:cTn id="1" dur="indefinite" restart="never" nodeType="tmRoot"/>
-      </p:par>
-    </p:tnLst>
-  </p:timing>
 </p:sld>
 </file>
 
@@ -9216,7 +9025,7 @@
         <p:cNvPr id="1" name="Shape 263">
           <a:extLst>
             <a:ext uri="{FF2B5EF4-FFF2-40B4-BE49-F238E27FC236}">
-              <a16:creationId xmlns:a16="http://schemas.microsoft.com/office/drawing/2014/main" xmlns="" id="{1683D3BF-B4ED-42E6-86A6-2A1EAF00F992}"/>
+              <a16:creationId xmlns:a16="http://schemas.microsoft.com/office/drawing/2014/main" id="{1683D3BF-B4ED-42E6-86A6-2A1EAF00F992}"/>
             </a:ext>
           </a:extLst>
         </p:cNvPr>
@@ -9236,7 +9045,7 @@
           <p:cNvPr id="266" name="Google Shape;266;p22">
             <a:extLst>
               <a:ext uri="{FF2B5EF4-FFF2-40B4-BE49-F238E27FC236}">
-                <a16:creationId xmlns:a16="http://schemas.microsoft.com/office/drawing/2014/main" xmlns="" id="{6C4CB194-3F99-F963-06DC-A6BAC75D6959}"/>
+                <a16:creationId xmlns:a16="http://schemas.microsoft.com/office/drawing/2014/main" id="{6C4CB194-3F99-F963-06DC-A6BAC75D6959}"/>
               </a:ext>
             </a:extLst>
           </p:cNvPr>
@@ -9268,7 +9077,7 @@
           <p:cNvPr id="267" name="Google Shape;267;p22">
             <a:extLst>
               <a:ext uri="{FF2B5EF4-FFF2-40B4-BE49-F238E27FC236}">
-                <a16:creationId xmlns:a16="http://schemas.microsoft.com/office/drawing/2014/main" xmlns="" id="{BAA337C0-DD81-20FF-0DC1-703222A2DE86}"/>
+                <a16:creationId xmlns:a16="http://schemas.microsoft.com/office/drawing/2014/main" id="{BAA337C0-DD81-20FF-0DC1-703222A2DE86}"/>
               </a:ext>
             </a:extLst>
           </p:cNvPr>
@@ -9300,7 +9109,7 @@
           <p:cNvPr id="268" name="Google Shape;268;p22">
             <a:extLst>
               <a:ext uri="{FF2B5EF4-FFF2-40B4-BE49-F238E27FC236}">
-                <a16:creationId xmlns:a16="http://schemas.microsoft.com/office/drawing/2014/main" xmlns="" id="{36797858-C2D6-AD12-CC43-19AC586EB4A4}"/>
+                <a16:creationId xmlns:a16="http://schemas.microsoft.com/office/drawing/2014/main" id="{36797858-C2D6-AD12-CC43-19AC586EB4A4}"/>
               </a:ext>
             </a:extLst>
           </p:cNvPr>
@@ -9348,7 +9157,7 @@
           <p:cNvPr id="2" name="Picture 1">
             <a:extLst>
               <a:ext uri="{FF2B5EF4-FFF2-40B4-BE49-F238E27FC236}">
-                <a16:creationId xmlns:a16="http://schemas.microsoft.com/office/drawing/2014/main" xmlns="" id="{98E9E19C-C61E-9265-7C44-B705FBED9971}"/>
+                <a16:creationId xmlns:a16="http://schemas.microsoft.com/office/drawing/2014/main" id="{98E9E19C-C61E-9265-7C44-B705FBED9971}"/>
               </a:ext>
             </a:extLst>
           </p:cNvPr>
@@ -9389,7 +9198,7 @@
           <p:cNvPr id="3" name="Picture 2">
             <a:extLst>
               <a:ext uri="{FF2B5EF4-FFF2-40B4-BE49-F238E27FC236}">
-                <a16:creationId xmlns:a16="http://schemas.microsoft.com/office/drawing/2014/main" xmlns="" id="{F87FEBCD-AFA2-ADAD-BFA3-A9AACDD09556}"/>
+                <a16:creationId xmlns:a16="http://schemas.microsoft.com/office/drawing/2014/main" id="{F87FEBCD-AFA2-ADAD-BFA3-A9AACDD09556}"/>
               </a:ext>
             </a:extLst>
           </p:cNvPr>
@@ -9430,7 +9239,7 @@
           <p:cNvPr id="4" name="TextBox 3">
             <a:extLst>
               <a:ext uri="{FF2B5EF4-FFF2-40B4-BE49-F238E27FC236}">
-                <a16:creationId xmlns:a16="http://schemas.microsoft.com/office/drawing/2014/main" xmlns="" id="{BE31FBEF-70B0-2A0D-07F3-5A0102AC4CDC}"/>
+                <a16:creationId xmlns:a16="http://schemas.microsoft.com/office/drawing/2014/main" id="{BE31FBEF-70B0-2A0D-07F3-5A0102AC4CDC}"/>
               </a:ext>
             </a:extLst>
           </p:cNvPr>
@@ -9469,8 +9278,13 @@
             </a:pPr>
             <a:r>
               <a:rPr lang="en-CA" dirty="0"/>
-              <a:t>Does this suggest non-linear relations between comorbid health factors?</a:t>
-            </a:r>
+              <a:t>Linear / non-linear relations </a:t>
+            </a:r>
+            <a:r>
+              <a:rPr lang="en-CA"/>
+              <a:t>no correlation &lt; 0.5</a:t>
+            </a:r>
+            <a:endParaRPr lang="en-CA" dirty="0"/>
           </a:p>
         </p:txBody>
       </p:sp>
@@ -9487,13 +9301,6 @@
   <p:transition>
     <p:push/>
   </p:transition>
-  <p:timing>
-    <p:tnLst>
-      <p:par>
-        <p:cTn id="1" dur="indefinite" restart="never" nodeType="tmRoot"/>
-      </p:par>
-    </p:tnLst>
-  </p:timing>
 </p:sld>
 </file>
 
@@ -9505,7 +9312,7 @@
         <p:cNvPr id="1" name="Shape 274">
           <a:extLst>
             <a:ext uri="{FF2B5EF4-FFF2-40B4-BE49-F238E27FC236}">
-              <a16:creationId xmlns:a16="http://schemas.microsoft.com/office/drawing/2014/main" xmlns="" id="{D4560813-2923-7F73-656A-6594E575DBC9}"/>
+              <a16:creationId xmlns:a16="http://schemas.microsoft.com/office/drawing/2014/main" id="{D4560813-2923-7F73-656A-6594E575DBC9}"/>
             </a:ext>
           </a:extLst>
         </p:cNvPr>
@@ -9525,7 +9332,7 @@
           <p:cNvPr id="278" name="Google Shape;278;p23">
             <a:extLst>
               <a:ext uri="{FF2B5EF4-FFF2-40B4-BE49-F238E27FC236}">
-                <a16:creationId xmlns:a16="http://schemas.microsoft.com/office/drawing/2014/main" xmlns="" id="{CEC4A98B-F1A1-0DEB-A3FE-E6F2991CED65}"/>
+                <a16:creationId xmlns:a16="http://schemas.microsoft.com/office/drawing/2014/main" id="{CEC4A98B-F1A1-0DEB-A3FE-E6F2991CED65}"/>
               </a:ext>
             </a:extLst>
           </p:cNvPr>
@@ -9580,7 +9387,7 @@
           <p:cNvPr id="279" name="Google Shape;279;p23">
             <a:extLst>
               <a:ext uri="{FF2B5EF4-FFF2-40B4-BE49-F238E27FC236}">
-                <a16:creationId xmlns:a16="http://schemas.microsoft.com/office/drawing/2014/main" xmlns="" id="{80C2D2E7-712E-6CB3-00B2-3EA19C4F4F3F}"/>
+                <a16:creationId xmlns:a16="http://schemas.microsoft.com/office/drawing/2014/main" id="{80C2D2E7-712E-6CB3-00B2-3EA19C4F4F3F}"/>
               </a:ext>
             </a:extLst>
           </p:cNvPr>
@@ -9680,13 +9487,6 @@
   <p:transition>
     <p:push/>
   </p:transition>
-  <p:timing>
-    <p:tnLst>
-      <p:par>
-        <p:cTn id="1" dur="indefinite" restart="never" nodeType="tmRoot"/>
-      </p:par>
-    </p:tnLst>
-  </p:timing>
 </p:sld>
 </file>
 
@@ -10287,7 +10087,7 @@
   <a:extraClrSchemeLst/>
   <a:extLst>
     <a:ext uri="{05A4C25C-085E-4340-85A3-A5531E510DB2}">
-      <thm15:themeFamily xmlns:thm15="http://schemas.microsoft.com/office/thememl/2012/main" xmlns="" name="Office Theme" id="{2E142A2C-CD16-42D6-873A-C26D2A0506FA}" vid="{1BDDFF52-6CD6-40A5-AB3C-68EB2F1E4D0A}"/>
+      <thm15:themeFamily xmlns:thm15="http://schemas.microsoft.com/office/thememl/2012/main" name="Office Theme" id="{2E142A2C-CD16-42D6-873A-C26D2A0506FA}" vid="{1BDDFF52-6CD6-40A5-AB3C-68EB2F1E4D0A}"/>
     </a:ext>
   </a:extLst>
 </a:theme>

</xml_diff>